<commit_message>
UI polish (numerals, animation transforms, stat grid), admin remove-hospital, 40-check smoke test, docs/model card/slides updated for self-registration and the new dashboard
</commit_message>
<xml_diff>
--- a/Multi-Hospital Disease Prediction/docs/slides.pptx
+++ b/Multi-Hospital Disease Prediction/docs/slides.pptx
@@ -4681,7 +4681,7 @@
               </a:defRPr>
             </a:pPr>
             <a:r>
-              <a:t>• Safeguards: stateless HMAC auth + throttle, stale-update 409, shape/NaN checks, update-norm cap, optional median aggregation</a:t>
+              <a:t>• Hospitals and sub-hospitals register themselves; hashed passwords, login throttle, stale-update 409, shape/NaN checks, update-size guard, optional median aggregation</a:t>
             </a:r>
           </a:p>
           <a:p>
@@ -4696,7 +4696,37 @@
               </a:defRPr>
             </a:pPr>
             <a:r>
-              <a:t>• Verified: 75 tests, 3 real client processes against a local server, and a live round on Render (v0 → v1)</a:t>
+              <a:t>• Dashboard: security of every round, raw data never leaves, DP status, attacks and risk score, ordinary-vs-protected demo, EDA</a:t>
+            </a:r>
+          </a:p>
+          <a:p>
+            <a:pPr>
+              <a:spcAft>
+                <a:spcPts val="800"/>
+              </a:spcAft>
+              <a:defRPr sz="2000">
+                <a:solidFill>
+                  <a:srgbClr val="0B0B0B"/>
+                </a:solidFill>
+              </a:defRPr>
+            </a:pPr>
+            <a:r>
+              <a:t>• Train &amp; Contribute: upload a CSV batch, train in the browser (optional DP), watch the round animate through to the Hugging Face update</a:t>
+            </a:r>
+          </a:p>
+          <a:p>
+            <a:pPr>
+              <a:spcAft>
+                <a:spcPts val="800"/>
+              </a:spcAft>
+              <a:defRPr sz="2000">
+                <a:solidFill>
+                  <a:srgbClr val="0B0B0B"/>
+                </a:solidFill>
+              </a:defRPr>
+            </a:pPr>
+            <a:r>
+              <a:t>• Verified: 99 tests, a real-browser end-to-end round with two hospitals, and a black-box smoke test of the deployment</a:t>
             </a:r>
           </a:p>
         </p:txBody>

</xml_diff>